<commit_message>
docs: add Biren to the adoption logos
Keep five rows and place Biren Technology at the end of the last row.
Update the PNG and editable PowerPoint source together.

Signed-off-by: Hao Lin <linhaomails@gmail.com>
</commit_message>
<xml_diff>
--- a/pic/adoption_logos/adoption.pptx
+++ b/pic/adoption_logos/adoption.pptx
@@ -7,7 +7,7 @@
   <p:sldIdLst>
     <p:sldId id="256" r:id="rId2"/>
   </p:sldIdLst>
-  <p:sldSz cx="12192000" cy="6858000"/>
+  <p:sldSz cx="10162000" cy="3940000"/>
   <p:notesSz cx="6858000" cy="9144000"/>
   <p:defaultTextStyle>
     <a:defPPr>
@@ -3349,7 +3349,7 @@
         </p:blipFill>
         <p:spPr>
           <a:xfrm>
-            <a:off x="5627338" y="582995"/>
+            <a:off x="5627338" y="147995"/>
             <a:ext cx="2697824" cy="468000"/>
           </a:xfrm>
           <a:prstGeom prst="rect">
@@ -3380,7 +3380,7 @@
         </p:blipFill>
         <p:spPr>
           <a:xfrm>
-            <a:off x="2761381" y="658826"/>
+            <a:off x="2761381" y="223826"/>
             <a:ext cx="2731298" cy="360000"/>
           </a:xfrm>
           <a:prstGeom prst="rect">
@@ -3410,7 +3410,7 @@
         </p:blipFill>
         <p:spPr>
           <a:xfrm>
-            <a:off x="324266" y="1365111"/>
+            <a:off x="324266" y="930111"/>
             <a:ext cx="1524774" cy="468000"/>
           </a:xfrm>
           <a:prstGeom prst="rect">
@@ -3440,7 +3440,7 @@
         </p:blipFill>
         <p:spPr>
           <a:xfrm>
-            <a:off x="8459821" y="614442"/>
+            <a:off x="8459821" y="179442"/>
             <a:ext cx="1497493" cy="432000"/>
           </a:xfrm>
           <a:prstGeom prst="rect">
@@ -3471,7 +3471,7 @@
         </p:blipFill>
         <p:spPr>
           <a:xfrm>
-            <a:off x="204464" y="654995"/>
+            <a:off x="204464" y="219995"/>
             <a:ext cx="2450710" cy="360000"/>
           </a:xfrm>
           <a:prstGeom prst="rect">
@@ -3502,7 +3502,7 @@
         </p:blipFill>
         <p:spPr>
           <a:xfrm>
-            <a:off x="2356325" y="1365111"/>
+            <a:off x="2356325" y="930111"/>
             <a:ext cx="1961345" cy="468000"/>
           </a:xfrm>
           <a:prstGeom prst="rect">
@@ -3525,7 +3525,7 @@
           <p:nvPr/>
         </p:nvPicPr>
         <p:blipFill>
-          <a:blip>
+          <a:blip r:embed="rId24">
             <a:extLst>
               <a:ext uri="{96DAC541-7B7A-43D3-8B79-37D633B846F1}">
                 <asvg:svgBlip xmlns:asvg="http://schemas.microsoft.com/office/drawing/2016/SVG/main" r:embed="rId8"/>
@@ -3539,7 +3539,7 @@
         </p:blipFill>
         <p:spPr>
           <a:xfrm>
-            <a:off x="4824955" y="1365111"/>
+            <a:off x="4824955" y="930111"/>
             <a:ext cx="2066676" cy="468000"/>
           </a:xfrm>
           <a:prstGeom prst="rect">
@@ -3562,7 +3562,7 @@
           <p:nvPr/>
         </p:nvPicPr>
         <p:blipFill>
-          <a:blip>
+          <a:blip r:embed="rId25">
             <a:extLst>
               <a:ext uri="{96DAC541-7B7A-43D3-8B79-37D633B846F1}">
                 <asvg:svgBlip xmlns:asvg="http://schemas.microsoft.com/office/drawing/2016/SVG/main" r:embed="rId9"/>
@@ -3575,7 +3575,7 @@
         </p:blipFill>
         <p:spPr>
           <a:xfrm>
-            <a:off x="7398915" y="1365111"/>
+            <a:off x="7398915" y="930111"/>
             <a:ext cx="2558399" cy="468000"/>
           </a:xfrm>
           <a:prstGeom prst="rect">
@@ -3605,7 +3605,7 @@
         </p:blipFill>
         <p:spPr>
           <a:xfrm>
-            <a:off x="324266" y="2179396"/>
+            <a:off x="324266" y="1744396"/>
             <a:ext cx="1485391" cy="468000"/>
           </a:xfrm>
           <a:prstGeom prst="rect">
@@ -3636,7 +3636,7 @@
         </p:blipFill>
         <p:spPr>
           <a:xfrm>
-            <a:off x="2575001" y="2179396"/>
+            <a:off x="2575001" y="1744396"/>
             <a:ext cx="963953" cy="468000"/>
           </a:xfrm>
           <a:prstGeom prst="rect">
@@ -3667,7 +3667,7 @@
         </p:blipFill>
         <p:spPr>
           <a:xfrm>
-            <a:off x="4304298" y="2179396"/>
+            <a:off x="4304298" y="1744396"/>
             <a:ext cx="1648048" cy="468000"/>
           </a:xfrm>
           <a:prstGeom prst="rect">
@@ -3698,7 +3698,7 @@
         </p:blipFill>
         <p:spPr>
           <a:xfrm>
-            <a:off x="6717690" y="2179396"/>
+            <a:off x="6717690" y="1744396"/>
             <a:ext cx="516632" cy="468000"/>
           </a:xfrm>
           <a:prstGeom prst="rect">
@@ -3735,7 +3735,7 @@
         </p:blipFill>
         <p:spPr bwMode="auto">
           <a:xfrm>
-            <a:off x="7999667" y="2179396"/>
+            <a:off x="7999667" y="1744396"/>
             <a:ext cx="1957647" cy="468000"/>
           </a:xfrm>
           <a:prstGeom prst="rect">
@@ -3782,7 +3782,7 @@
         </p:blipFill>
         <p:spPr bwMode="auto">
           <a:xfrm>
-            <a:off x="324266" y="2923349"/>
+            <a:off x="324266" y="2488349"/>
             <a:ext cx="1848368" cy="468000"/>
           </a:xfrm>
           <a:prstGeom prst="rect">
@@ -3829,7 +3829,7 @@
         </p:blipFill>
         <p:spPr bwMode="auto">
           <a:xfrm>
-            <a:off x="2723343" y="2923349"/>
+            <a:off x="2723343" y="2488349"/>
             <a:ext cx="3167163" cy="468000"/>
           </a:xfrm>
           <a:prstGeom prst="rect">
@@ -3869,7 +3869,7 @@
         </p:blipFill>
         <p:spPr>
           <a:xfrm>
-            <a:off x="6333641" y="2923349"/>
+            <a:off x="6333641" y="2488349"/>
             <a:ext cx="1448000" cy="468000"/>
           </a:xfrm>
           <a:prstGeom prst="rect">
@@ -3906,7 +3906,7 @@
         </p:blipFill>
         <p:spPr bwMode="auto">
           <a:xfrm>
-            <a:off x="8167607" y="2923349"/>
+            <a:off x="8167607" y="2488349"/>
             <a:ext cx="1789707" cy="468000"/>
           </a:xfrm>
           <a:prstGeom prst="rect">
@@ -3953,7 +3953,7 @@
         </p:blipFill>
         <p:spPr bwMode="auto">
           <a:xfrm>
-            <a:off x="324266" y="3691397"/>
+            <a:off x="324266" y="3256397"/>
             <a:ext cx="918453" cy="468000"/>
           </a:xfrm>
           <a:prstGeom prst="rect">
@@ -3993,7 +3993,7 @@
         </p:blipFill>
         <p:spPr>
           <a:xfrm>
-            <a:off x="2001243" y="3637672"/>
+            <a:off x="1521938" y="3202672"/>
             <a:ext cx="874303" cy="575450"/>
           </a:xfrm>
           <a:prstGeom prst="rect">
@@ -4024,7 +4024,7 @@
         </p:blipFill>
         <p:spPr>
           <a:xfrm>
-            <a:off x="3634070" y="3673397"/>
+            <a:off x="2675461" y="3238397"/>
             <a:ext cx="1576512" cy="504000"/>
           </a:xfrm>
           <a:prstGeom prst="rect">
@@ -4055,7 +4055,7 @@
         </p:blipFill>
         <p:spPr>
           <a:xfrm>
-            <a:off x="5969106" y="3691397"/>
+            <a:off x="4531192" y="3256397"/>
             <a:ext cx="2021451" cy="468000"/>
           </a:xfrm>
           <a:prstGeom prst="rect">
@@ -4086,8 +4086,38 @@
         </p:blipFill>
         <p:spPr>
           <a:xfrm>
-            <a:off x="8749082" y="3691397"/>
+            <a:off x="6831863" y="3256397"/>
             <a:ext cx="1208232" cy="468000"/>
+          </a:xfrm>
+          <a:prstGeom prst="rect">
+            <a:avLst/>
+          </a:prstGeom>
+        </p:spPr>
+      </p:pic>
+      <p:pic>
+        <p:nvPicPr>
+          <p:cNvPr id="100" name="Biren Technology" descr="壁仞科技 / BIREN TECHNOLOGY"/>
+          <p:cNvPicPr>
+            <a:picLocks noChangeAspect="1"/>
+          </p:cNvPicPr>
+          <p:nvPr/>
+        </p:nvPicPr>
+        <p:blipFill>
+          <a:blip r:embed="rId27">
+            <a:extLst>
+              <a:ext uri="{96DAC541-7B7A-43D3-8B79-37D633B846F1}">
+                <asvg:svgBlip xmlns:asvg="http://schemas.microsoft.com/office/drawing/2016/SVG/main" r:embed="rId26"/>
+              </a:ext>
+            </a:extLst>
+          </a:blip>
+          <a:stretch>
+            <a:fillRect/>
+          </a:stretch>
+        </p:blipFill>
+        <p:spPr>
+          <a:xfrm>
+            <a:off x="8319314" y="3256397"/>
+            <a:ext cx="1638000" cy="468000"/>
           </a:xfrm>
           <a:prstGeom prst="rect">
             <a:avLst/>

</xml_diff>

<commit_message>
docs: add MetaX to the adoption logos
Signed-off-by: Hao Lin <linhaomails@gmail.com>
</commit_message>
<xml_diff>
--- a/pic/adoption_logos/adoption.pptx
+++ b/pic/adoption_logos/adoption.pptx
@@ -3500,7 +3500,7 @@
           <p:nvPr/>
         </p:nvPicPr>
         <p:blipFill>
-          <a:blip>
+          <a:blip r:embed="rId24">
             <a:extLst>
               <a:ext uri="{96DAC541-7B7A-43D3-8B79-37D633B846F1}">
                 <asvg:svgBlip xmlns:asvg="http://schemas.microsoft.com/office/drawing/2016/SVG/main" r:embed="rId7"/>
@@ -3514,8 +3514,8 @@
         </p:blipFill>
         <p:spPr>
           <a:xfrm>
-            <a:off x="3482304" y="131607"/>
-            <a:ext cx="2224351" cy="503706"/>
+            <a:off x="2239284" y="185316"/>
+            <a:ext cx="1750000" cy="396289"/>
           </a:xfrm>
           <a:prstGeom prst="rect">
             <a:avLst/>
@@ -3537,7 +3537,7 @@
           <p:nvPr/>
         </p:nvPicPr>
         <p:blipFill>
-          <a:blip>
+          <a:blip r:embed="rId25">
             <a:extLst>
               <a:ext uri="{96DAC541-7B7A-43D3-8B79-37D633B846F1}">
                 <asvg:svgBlip xmlns:asvg="http://schemas.microsoft.com/office/drawing/2016/SVG/main" r:embed="rId8"/>
@@ -3550,8 +3550,8 @@
         </p:blipFill>
         <p:spPr>
           <a:xfrm>
-            <a:off x="279128" y="167032"/>
-            <a:ext cx="2366279" cy="432856"/>
+            <a:off x="323647" y="223399"/>
+            <a:ext cx="1750000" cy="320122"/>
           </a:xfrm>
           <a:prstGeom prst="rect">
             <a:avLst/>
@@ -3710,7 +3710,7 @@
         </p:blipFill>
         <p:spPr bwMode="auto">
           <a:xfrm>
-            <a:off x="8231195" y="201202"/>
+            <a:off x="6183170" y="201202"/>
             <a:ext cx="1524774" cy="364516"/>
           </a:xfrm>
           <a:prstGeom prst="rect">
@@ -3968,7 +3968,7 @@
         </p:blipFill>
         <p:spPr>
           <a:xfrm>
-            <a:off x="6543552" y="103488"/>
+            <a:off x="4604548" y="103488"/>
             <a:ext cx="850746" cy="559945"/>
           </a:xfrm>
           <a:prstGeom prst="rect">
@@ -4084,7 +4084,7 @@
           <p:nvPr/>
         </p:nvPicPr>
         <p:blipFill>
-          <a:blip>
+          <a:blip r:embed="rId26">
             <a:extLst>
               <a:ext uri="{96DAC541-7B7A-43D3-8B79-37D633B846F1}">
                 <asvg:svgBlip xmlns:asvg="http://schemas.microsoft.com/office/drawing/2016/SVG/main" r:embed="rId23"/>
@@ -4148,6 +4148,36 @@
           </a:fontRef>
         </p:style>
       </p:cxnSp>
+      <p:pic>
+        <p:nvPicPr>
+          <p:cNvPr id="1031" name="MetaX" descr="MetaX 沐曦 — https://www.metax-tech.com/"/>
+          <p:cNvPicPr>
+            <a:picLocks noChangeAspect="1"/>
+          </p:cNvPicPr>
+          <p:nvPr/>
+        </p:nvPicPr>
+        <p:blipFill>
+          <a:blip r:embed="rId27">
+            <a:extLst>
+              <a:ext uri="{96DAC541-7B7A-43D3-8B79-37D633B846F1}">
+                <asvg:svgBlip xmlns:asvg="http://schemas.microsoft.com/office/drawing/2016/SVG/main" r:embed="rId28"/>
+              </a:ext>
+            </a:extLst>
+          </a:blip>
+          <a:stretch>
+            <a:fillRect/>
+          </a:stretch>
+        </p:blipFill>
+        <p:spPr>
+          <a:xfrm>
+            <a:off x="7986194" y="171826"/>
+            <a:ext cx="1750000" cy="423269"/>
+          </a:xfrm>
+          <a:prstGeom prst="rect">
+            <a:avLst/>
+          </a:prstGeom>
+        </p:spPr>
+      </p:pic>
     </p:spTree>
     <p:extLst>
       <p:ext uri="{BB962C8B-B14F-4D97-AF65-F5344CB8AC3E}">

</xml_diff>